<commit_message>
feat: simple, self-contained labs for GenAI for Engineers v2.4
Every lab now works directly on the files in its own data folder: no
extra work folder, no copying between folders and no dependence on
finishing an earlier lab. Lab 2 ships the finished Lab 1 workbook and
Word brief; Lab 6 and Lab 10 ship ready-made decks to improve.

Steps follow the C34 style: a short headline, the exact clicks, what
you should see, and one plain-English prompt (one paste, no blank
lines). Steps without a prompt get a "What you should see" checklist
box on the prompts page instead of a Copy button. Skill installs use
the OneDrive folder-upload route; SKILL.md authoring moves to an
optional Challenge.

Also: Excel desktop works on local files (no OneDrive upload), the
deck compares local upload with OneDrive references, and the v2.3
deck is superseded by v2.4.

Co-Authored-By: Claude Opus 5.5 <noreply@anthropic.com>
</commit_message>
<xml_diff>
--- a/labs/lab-02-word-to-powerpoint-and-outlook/data/templates/Northstar_Management_Deck_Template.pptx
+++ b/labs/lab-02-word-to-powerpoint-and-outlook/data/templates/Northstar_Management_Deck_Template.pptx
@@ -9,10 +9,6 @@
     <p:sldId id="257" r:id="rId9"/>
     <p:sldId id="258" r:id="rId10"/>
     <p:sldId id="259" r:id="rId11"/>
-    <p:sldId id="260" r:id="rId12"/>
-    <p:sldId id="261" r:id="rId13"/>
-    <p:sldId id="262" r:id="rId14"/>
-    <p:sldId id="263" r:id="rId15"/>
   </p:sldIdLst>
   <p:sldSz cx="12191695" cy="6858000" type="screen4x3"/>
   <p:notesSz cx="6858000" cy="9144000"/>
@@ -675,286 +671,6 @@
 </file>
 
 <file path=ppt/notesSlides/notesSlide4.xml><?xml version="1.0" encoding="utf-8"?>
-<p:notes xmlns:a="http://schemas.openxmlformats.org/drawingml/2006/main" xmlns:p="http://schemas.openxmlformats.org/presentationml/2006/main" xmlns:r="http://schemas.openxmlformats.org/officeDocument/2006/relationships">
-  <p:cSld>
-    <p:spTree>
-      <p:nvGrpSpPr>
-        <p:cNvPr id="1" name=""/>
-        <p:cNvGrpSpPr/>
-        <p:nvPr/>
-      </p:nvGrpSpPr>
-      <p:grpSpPr>
-        <a:xfrm>
-          <a:off x="0" y="0"/>
-          <a:ext cx="0" cy="0"/>
-          <a:chOff x="0" y="0"/>
-          <a:chExt cx="0" cy="0"/>
-        </a:xfrm>
-      </p:grpSpPr>
-      <p:sp>
-        <p:nvSpPr>
-          <p:cNvPr id="2" name="Slide Image Placeholder 1"/>
-          <p:cNvSpPr>
-            <a:spLocks noGrp="1"/>
-          </p:cNvSpPr>
-          <p:nvPr>
-            <p:ph type="sldImg" idx="2"/>
-          </p:nvPr>
-        </p:nvSpPr>
-        <p:spPr/>
-      </p:sp>
-      <p:sp>
-        <p:nvSpPr>
-          <p:cNvPr id="3" name="Notes Placeholder 2"/>
-          <p:cNvSpPr>
-            <a:spLocks noGrp="1"/>
-          </p:cNvSpPr>
-          <p:nvPr>
-            <p:ph type="body" idx="3" sz="quarter"/>
-          </p:nvPr>
-        </p:nvSpPr>
-        <p:spPr/>
-        <p:txBody>
-          <a:bodyPr/>
-          <a:lstStyle/>
-          <a:p>
-            <a:r>
-              <a:t>Provide the selected verified snapshot and replace scaffold content. Add source/date/scope notes; do not invent facts.</a:t>
-            </a:r>
-          </a:p>
-        </p:txBody>
-      </p:sp>
-      <p:sp>
-        <p:nvSpPr>
-          <p:cNvPr id="4" name="Slide Number Placeholder 3"/>
-          <p:cNvSpPr>
-            <a:spLocks noGrp="1"/>
-          </p:cNvSpPr>
-          <p:nvPr>
-            <p:ph type="sldNum" idx="5" sz="quarter"/>
-          </p:nvPr>
-        </p:nvSpPr>
-        <p:spPr/>
-      </p:sp>
-    </p:spTree>
-  </p:cSld>
-  <p:clrMapOvr>
-    <a:masterClrMapping/>
-  </p:clrMapOvr>
-</p:notes>
-</file>
-
-<file path=ppt/notesSlides/notesSlide5.xml><?xml version="1.0" encoding="utf-8"?>
-<p:notes xmlns:a="http://schemas.openxmlformats.org/drawingml/2006/main" xmlns:p="http://schemas.openxmlformats.org/presentationml/2006/main" xmlns:r="http://schemas.openxmlformats.org/officeDocument/2006/relationships">
-  <p:cSld>
-    <p:spTree>
-      <p:nvGrpSpPr>
-        <p:cNvPr id="1" name=""/>
-        <p:cNvGrpSpPr/>
-        <p:nvPr/>
-      </p:nvGrpSpPr>
-      <p:grpSpPr>
-        <a:xfrm>
-          <a:off x="0" y="0"/>
-          <a:ext cx="0" cy="0"/>
-          <a:chOff x="0" y="0"/>
-          <a:chExt cx="0" cy="0"/>
-        </a:xfrm>
-      </p:grpSpPr>
-      <p:sp>
-        <p:nvSpPr>
-          <p:cNvPr id="2" name="Slide Image Placeholder 1"/>
-          <p:cNvSpPr>
-            <a:spLocks noGrp="1"/>
-          </p:cNvSpPr>
-          <p:nvPr>
-            <p:ph type="sldImg" idx="2"/>
-          </p:nvPr>
-        </p:nvSpPr>
-        <p:spPr/>
-      </p:sp>
-      <p:sp>
-        <p:nvSpPr>
-          <p:cNvPr id="3" name="Notes Placeholder 2"/>
-          <p:cNvSpPr>
-            <a:spLocks noGrp="1"/>
-          </p:cNvSpPr>
-          <p:nvPr>
-            <p:ph type="body" idx="3" sz="quarter"/>
-          </p:nvPr>
-        </p:nvSpPr>
-        <p:spPr/>
-        <p:txBody>
-          <a:bodyPr/>
-          <a:lstStyle/>
-          <a:p>
-            <a:r>
-              <a:t>Provide the selected verified snapshot and replace scaffold content. Add source/date/scope notes; do not invent facts.</a:t>
-            </a:r>
-          </a:p>
-        </p:txBody>
-      </p:sp>
-      <p:sp>
-        <p:nvSpPr>
-          <p:cNvPr id="4" name="Slide Number Placeholder 3"/>
-          <p:cNvSpPr>
-            <a:spLocks noGrp="1"/>
-          </p:cNvSpPr>
-          <p:nvPr>
-            <p:ph type="sldNum" idx="5" sz="quarter"/>
-          </p:nvPr>
-        </p:nvSpPr>
-        <p:spPr/>
-      </p:sp>
-    </p:spTree>
-  </p:cSld>
-  <p:clrMapOvr>
-    <a:masterClrMapping/>
-  </p:clrMapOvr>
-</p:notes>
-</file>
-
-<file path=ppt/notesSlides/notesSlide6.xml><?xml version="1.0" encoding="utf-8"?>
-<p:notes xmlns:a="http://schemas.openxmlformats.org/drawingml/2006/main" xmlns:p="http://schemas.openxmlformats.org/presentationml/2006/main" xmlns:r="http://schemas.openxmlformats.org/officeDocument/2006/relationships">
-  <p:cSld>
-    <p:spTree>
-      <p:nvGrpSpPr>
-        <p:cNvPr id="1" name=""/>
-        <p:cNvGrpSpPr/>
-        <p:nvPr/>
-      </p:nvGrpSpPr>
-      <p:grpSpPr>
-        <a:xfrm>
-          <a:off x="0" y="0"/>
-          <a:ext cx="0" cy="0"/>
-          <a:chOff x="0" y="0"/>
-          <a:chExt cx="0" cy="0"/>
-        </a:xfrm>
-      </p:grpSpPr>
-      <p:sp>
-        <p:nvSpPr>
-          <p:cNvPr id="2" name="Slide Image Placeholder 1"/>
-          <p:cNvSpPr>
-            <a:spLocks noGrp="1"/>
-          </p:cNvSpPr>
-          <p:nvPr>
-            <p:ph type="sldImg" idx="2"/>
-          </p:nvPr>
-        </p:nvSpPr>
-        <p:spPr/>
-      </p:sp>
-      <p:sp>
-        <p:nvSpPr>
-          <p:cNvPr id="3" name="Notes Placeholder 2"/>
-          <p:cNvSpPr>
-            <a:spLocks noGrp="1"/>
-          </p:cNvSpPr>
-          <p:nvPr>
-            <p:ph type="body" idx="3" sz="quarter"/>
-          </p:nvPr>
-        </p:nvSpPr>
-        <p:spPr/>
-        <p:txBody>
-          <a:bodyPr/>
-          <a:lstStyle/>
-          <a:p>
-            <a:r>
-              <a:t>Provide the selected verified snapshot and replace scaffold content. Add source/date/scope notes; do not invent facts.</a:t>
-            </a:r>
-          </a:p>
-        </p:txBody>
-      </p:sp>
-      <p:sp>
-        <p:nvSpPr>
-          <p:cNvPr id="4" name="Slide Number Placeholder 3"/>
-          <p:cNvSpPr>
-            <a:spLocks noGrp="1"/>
-          </p:cNvSpPr>
-          <p:nvPr>
-            <p:ph type="sldNum" idx="5" sz="quarter"/>
-          </p:nvPr>
-        </p:nvSpPr>
-        <p:spPr/>
-      </p:sp>
-    </p:spTree>
-  </p:cSld>
-  <p:clrMapOvr>
-    <a:masterClrMapping/>
-  </p:clrMapOvr>
-</p:notes>
-</file>
-
-<file path=ppt/notesSlides/notesSlide7.xml><?xml version="1.0" encoding="utf-8"?>
-<p:notes xmlns:a="http://schemas.openxmlformats.org/drawingml/2006/main" xmlns:p="http://schemas.openxmlformats.org/presentationml/2006/main" xmlns:r="http://schemas.openxmlformats.org/officeDocument/2006/relationships">
-  <p:cSld>
-    <p:spTree>
-      <p:nvGrpSpPr>
-        <p:cNvPr id="1" name=""/>
-        <p:cNvGrpSpPr/>
-        <p:nvPr/>
-      </p:nvGrpSpPr>
-      <p:grpSpPr>
-        <a:xfrm>
-          <a:off x="0" y="0"/>
-          <a:ext cx="0" cy="0"/>
-          <a:chOff x="0" y="0"/>
-          <a:chExt cx="0" cy="0"/>
-        </a:xfrm>
-      </p:grpSpPr>
-      <p:sp>
-        <p:nvSpPr>
-          <p:cNvPr id="2" name="Slide Image Placeholder 1"/>
-          <p:cNvSpPr>
-            <a:spLocks noGrp="1"/>
-          </p:cNvSpPr>
-          <p:nvPr>
-            <p:ph type="sldImg" idx="2"/>
-          </p:nvPr>
-        </p:nvSpPr>
-        <p:spPr/>
-      </p:sp>
-      <p:sp>
-        <p:nvSpPr>
-          <p:cNvPr id="3" name="Notes Placeholder 2"/>
-          <p:cNvSpPr>
-            <a:spLocks noGrp="1"/>
-          </p:cNvSpPr>
-          <p:nvPr>
-            <p:ph type="body" idx="3" sz="quarter"/>
-          </p:nvPr>
-        </p:nvSpPr>
-        <p:spPr/>
-        <p:txBody>
-          <a:bodyPr/>
-          <a:lstStyle/>
-          <a:p>
-            <a:r>
-              <a:t>Provide the selected verified snapshot and replace scaffold content. Add source/date/scope notes; do not invent facts.</a:t>
-            </a:r>
-          </a:p>
-        </p:txBody>
-      </p:sp>
-      <p:sp>
-        <p:nvSpPr>
-          <p:cNvPr id="4" name="Slide Number Placeholder 3"/>
-          <p:cNvSpPr>
-            <a:spLocks noGrp="1"/>
-          </p:cNvSpPr>
-          <p:nvPr>
-            <p:ph type="sldNum" idx="5" sz="quarter"/>
-          </p:nvPr>
-        </p:nvSpPr>
-        <p:spPr/>
-      </p:sp>
-    </p:spTree>
-  </p:cSld>
-  <p:clrMapOvr>
-    <a:masterClrMapping/>
-  </p:clrMapOvr>
-</p:notes>
-</file>
-
-<file path=ppt/notesSlides/notesSlide8.xml><?xml version="1.0" encoding="utf-8"?>
 <p:notes xmlns:a="http://schemas.openxmlformats.org/drawingml/2006/main" xmlns:p="http://schemas.openxmlformats.org/presentationml/2006/main" xmlns:r="http://schemas.openxmlformats.org/officeDocument/2006/relationships">
   <p:cSld>
     <p:spTree>
@@ -4035,7 +3751,7 @@
               </a:defRPr>
             </a:pPr>
             <a:r>
-              <a:t>Q3 maintenance: prioritise the overdue backlog</a:t>
+              <a:t>Northstar maintenance portfolio - 30 September</a:t>
             </a:r>
           </a:p>
         </p:txBody>
@@ -4097,7 +3813,7 @@
               <a:defRPr sz="1000"/>
             </a:pPr>
             <a:r>
-              <a:t>GenAI for Engineers v2.3 | Synthetic Northstar example | 2026-09-30 | All filters All | Slide1</a:t>
+              <a:t>GenAI for Engineers v2.4 | Synthetic Northstar example | 2026-09-30 | All filters All | Slide1</a:t>
             </a:r>
           </a:p>
         </p:txBody>
@@ -4150,7 +3866,7 @@
               </a:defRPr>
             </a:pPr>
             <a:r>
-              <a:t>120 orders: reconcile the portfolio</a:t>
+              <a:t>50 of 60 backlog orders are overdue</a:t>
             </a:r>
           </a:p>
         </p:txBody>
@@ -4212,7 +3928,7 @@
               <a:defRPr sz="1000"/>
             </a:pPr>
             <a:r>
-              <a:t>GenAI for Engineers v2.3 | Synthetic Northstar example | 2026-09-30 | All filters All | Slide2</a:t>
+              <a:t>GenAI for Engineers v2.4 | Synthetic Northstar example | 2026-09-30 | All filters All | Slide2</a:t>
             </a:r>
           </a:p>
         </p:txBody>
@@ -4265,7 +3981,7 @@
               </a:defRPr>
             </a:pPr>
             <a:r>
-              <a:t>Site backlog: compare open work</a:t>
+              <a:t>6 backlog orders need an assignment proposal</a:t>
             </a:r>
           </a:p>
         </p:txBody>
@@ -4327,7 +4043,7 @@
               <a:defRPr sz="1000"/>
             </a:pPr>
             <a:r>
-              <a:t>GenAI for Engineers v2.3 | Synthetic Northstar example | 2026-09-30 | All filters All | Slide3</a:t>
+              <a:t>GenAI for Engineers v2.4 | Synthetic Northstar example | 2026-09-30 | All filters All | Slide3</a:t>
             </a:r>
           </a:p>
         </p:txBody>
@@ -4380,7 +4096,7 @@
               </a:defRPr>
             </a:pPr>
             <a:r>
-              <a:t>Status and category mix</a:t>
+              <a:t>Decision requested: review the proposed priorities</a:t>
             </a:r>
           </a:p>
         </p:txBody>
@@ -4442,467 +4158,7 @@
               <a:defRPr sz="1000"/>
             </a:pPr>
             <a:r>
-              <a:t>GenAI for Engineers v2.3 | Synthetic Northstar example | 2026-09-30 | All filters All | Slide4</a:t>
-            </a:r>
-          </a:p>
-        </p:txBody>
-      </p:sp>
-    </p:spTree>
-  </p:cSld>
-  <p:clrMapOvr>
-    <a:masterClrMapping/>
-  </p:clrMapOvr>
-</p:sld>
-</file>
-
-<file path=ppt/slides/slide5.xml><?xml version="1.0" encoding="utf-8"?>
-<p:sld xmlns:a="http://schemas.openxmlformats.org/drawingml/2006/main" xmlns:p="http://schemas.openxmlformats.org/presentationml/2006/main" xmlns:r="http://schemas.openxmlformats.org/officeDocument/2006/relationships">
-  <p:cSld>
-    <p:spTree>
-      <p:nvGrpSpPr>
-        <p:cNvPr id="1" name=""/>
-        <p:cNvGrpSpPr/>
-        <p:nvPr/>
-      </p:nvGrpSpPr>
-      <p:grpSpPr/>
-      <p:sp>
-        <p:nvSpPr>
-          <p:cNvPr id="2" name="TextBox 1"/>
-          <p:cNvSpPr txBox="1"/>
-          <p:nvPr/>
-        </p:nvSpPr>
-        <p:spPr>
-          <a:xfrm>
-            <a:off x="640080" y="457200"/>
-            <a:ext cx="10972800" cy="914400"/>
-          </a:xfrm>
-          <a:prstGeom prst="rect">
-            <a:avLst/>
-          </a:prstGeom>
-          <a:noFill/>
-        </p:spPr>
-        <p:txBody>
-          <a:bodyPr wrap="none">
-            <a:spAutoFit/>
-          </a:bodyPr>
-          <a:lstStyle/>
-          <a:p>
-            <a:pPr>
-              <a:defRPr sz="3000" b="1">
-                <a:solidFill>
-                  <a:srgbClr val="0B3060"/>
-                </a:solidFill>
-              </a:defRPr>
-            </a:pPr>
-            <a:r>
-              <a:t>30 of 48 closures were on time</a:t>
-            </a:r>
-          </a:p>
-        </p:txBody>
-      </p:sp>
-      <p:sp>
-        <p:nvSpPr>
-          <p:cNvPr id="3" name="TextBox 2"/>
-          <p:cNvSpPr txBox="1"/>
-          <p:nvPr/>
-        </p:nvSpPr>
-        <p:spPr>
-          <a:xfrm>
-            <a:off x="731520" y="1508760"/>
-            <a:ext cx="10698480" cy="3291840"/>
-          </a:xfrm>
-          <a:prstGeom prst="rect">
-            <a:avLst/>
-          </a:prstGeom>
-          <a:noFill/>
-        </p:spPr>
-        <p:txBody>
-          <a:bodyPr wrap="square">
-            <a:spAutoFit/>
-          </a:bodyPr>
-          <a:lstStyle/>
-          <a:p>
-            <a:pPr>
-              <a:defRPr sz="2000"/>
-            </a:pPr>
-            <a:r>
-              <a:t>Add the verified chart or evidence table for this slide. Separate observed facts from proposed actions.</a:t>
-            </a:r>
-          </a:p>
-        </p:txBody>
-      </p:sp>
-      <p:sp>
-        <p:nvSpPr>
-          <p:cNvPr id="4" name="TextBox 3"/>
-          <p:cNvSpPr txBox="1"/>
-          <p:nvPr/>
-        </p:nvSpPr>
-        <p:spPr>
-          <a:xfrm>
-            <a:off x="731520" y="6217920"/>
-            <a:ext cx="10698480" cy="320040"/>
-          </a:xfrm>
-          <a:prstGeom prst="rect">
-            <a:avLst/>
-          </a:prstGeom>
-          <a:noFill/>
-        </p:spPr>
-        <p:txBody>
-          <a:bodyPr wrap="none">
-            <a:spAutoFit/>
-          </a:bodyPr>
-          <a:lstStyle/>
-          <a:p>
-            <a:pPr>
-              <a:defRPr sz="1000"/>
-            </a:pPr>
-            <a:r>
-              <a:t>GenAI for Engineers v2.3 | Synthetic Northstar example | 2026-09-30 | All filters All | Slide5</a:t>
-            </a:r>
-          </a:p>
-        </p:txBody>
-      </p:sp>
-    </p:spTree>
-  </p:cSld>
-  <p:clrMapOvr>
-    <a:masterClrMapping/>
-  </p:clrMapOvr>
-</p:sld>
-</file>
-
-<file path=ppt/slides/slide6.xml><?xml version="1.0" encoding="utf-8"?>
-<p:sld xmlns:a="http://schemas.openxmlformats.org/drawingml/2006/main" xmlns:p="http://schemas.openxmlformats.org/presentationml/2006/main" xmlns:r="http://schemas.openxmlformats.org/officeDocument/2006/relationships">
-  <p:cSld>
-    <p:spTree>
-      <p:nvGrpSpPr>
-        <p:cNvPr id="1" name=""/>
-        <p:cNvGrpSpPr/>
-        <p:nvPr/>
-      </p:nvGrpSpPr>
-      <p:grpSpPr/>
-      <p:sp>
-        <p:nvSpPr>
-          <p:cNvPr id="2" name="TextBox 1"/>
-          <p:cNvSpPr txBox="1"/>
-          <p:nvPr/>
-        </p:nvSpPr>
-        <p:spPr>
-          <a:xfrm>
-            <a:off x="640080" y="457200"/>
-            <a:ext cx="10972800" cy="914400"/>
-          </a:xfrm>
-          <a:prstGeom prst="rect">
-            <a:avLst/>
-          </a:prstGeom>
-          <a:noFill/>
-        </p:spPr>
-        <p:txBody>
-          <a:bodyPr wrap="none">
-            <a:spAutoFit/>
-          </a:bodyPr>
-          <a:lstStyle/>
-          <a:p>
-            <a:pPr>
-              <a:defRPr sz="3000" b="1">
-                <a:solidFill>
-                  <a:srgbClr val="0B3060"/>
-                </a:solidFill>
-              </a:defRPr>
-            </a:pPr>
-            <a:r>
-              <a:t>6 backlog orders have no current owner</a:t>
-            </a:r>
-          </a:p>
-        </p:txBody>
-      </p:sp>
-      <p:sp>
-        <p:nvSpPr>
-          <p:cNvPr id="3" name="TextBox 2"/>
-          <p:cNvSpPr txBox="1"/>
-          <p:nvPr/>
-        </p:nvSpPr>
-        <p:spPr>
-          <a:xfrm>
-            <a:off x="731520" y="1508760"/>
-            <a:ext cx="10698480" cy="3291840"/>
-          </a:xfrm>
-          <a:prstGeom prst="rect">
-            <a:avLst/>
-          </a:prstGeom>
-          <a:noFill/>
-        </p:spPr>
-        <p:txBody>
-          <a:bodyPr wrap="square">
-            <a:spAutoFit/>
-          </a:bodyPr>
-          <a:lstStyle/>
-          <a:p>
-            <a:pPr>
-              <a:defRPr sz="2000"/>
-            </a:pPr>
-            <a:r>
-              <a:t>Add the verified chart or evidence table for this slide. Separate observed facts from proposed actions.</a:t>
-            </a:r>
-          </a:p>
-        </p:txBody>
-      </p:sp>
-      <p:sp>
-        <p:nvSpPr>
-          <p:cNvPr id="4" name="TextBox 3"/>
-          <p:cNvSpPr txBox="1"/>
-          <p:nvPr/>
-        </p:nvSpPr>
-        <p:spPr>
-          <a:xfrm>
-            <a:off x="731520" y="6217920"/>
-            <a:ext cx="10698480" cy="320040"/>
-          </a:xfrm>
-          <a:prstGeom prst="rect">
-            <a:avLst/>
-          </a:prstGeom>
-          <a:noFill/>
-        </p:spPr>
-        <p:txBody>
-          <a:bodyPr wrap="none">
-            <a:spAutoFit/>
-          </a:bodyPr>
-          <a:lstStyle/>
-          <a:p>
-            <a:pPr>
-              <a:defRPr sz="1000"/>
-            </a:pPr>
-            <a:r>
-              <a:t>GenAI for Engineers v2.3 | Synthetic Northstar example | 2026-09-30 | All filters All | Slide6</a:t>
-            </a:r>
-          </a:p>
-        </p:txBody>
-      </p:sp>
-    </p:spTree>
-  </p:cSld>
-  <p:clrMapOvr>
-    <a:masterClrMapping/>
-  </p:clrMapOvr>
-</p:sld>
-</file>
-
-<file path=ppt/slides/slide7.xml><?xml version="1.0" encoding="utf-8"?>
-<p:sld xmlns:a="http://schemas.openxmlformats.org/drawingml/2006/main" xmlns:p="http://schemas.openxmlformats.org/presentationml/2006/main" xmlns:r="http://schemas.openxmlformats.org/officeDocument/2006/relationships">
-  <p:cSld>
-    <p:spTree>
-      <p:nvGrpSpPr>
-        <p:cNvPr id="1" name=""/>
-        <p:cNvGrpSpPr/>
-        <p:nvPr/>
-      </p:nvGrpSpPr>
-      <p:grpSpPr/>
-      <p:sp>
-        <p:nvSpPr>
-          <p:cNvPr id="2" name="TextBox 1"/>
-          <p:cNvSpPr txBox="1"/>
-          <p:nvPr/>
-        </p:nvSpPr>
-        <p:spPr>
-          <a:xfrm>
-            <a:off x="640080" y="457200"/>
-            <a:ext cx="10972800" cy="914400"/>
-          </a:xfrm>
-          <a:prstGeom prst="rect">
-            <a:avLst/>
-          </a:prstGeom>
-          <a:noFill/>
-        </p:spPr>
-        <p:txBody>
-          <a:bodyPr wrap="none">
-            <a:spAutoFit/>
-          </a:bodyPr>
-          <a:lstStyle/>
-          <a:p>
-            <a:pPr>
-              <a:defRPr sz="3000" b="1">
-                <a:solidFill>
-                  <a:srgbClr val="0B3060"/>
-                </a:solidFill>
-              </a:defRPr>
-            </a:pPr>
-            <a:r>
-              <a:t>Proposed recovery actions and trade-offs</a:t>
-            </a:r>
-          </a:p>
-        </p:txBody>
-      </p:sp>
-      <p:sp>
-        <p:nvSpPr>
-          <p:cNvPr id="3" name="TextBox 2"/>
-          <p:cNvSpPr txBox="1"/>
-          <p:nvPr/>
-        </p:nvSpPr>
-        <p:spPr>
-          <a:xfrm>
-            <a:off x="731520" y="1508760"/>
-            <a:ext cx="10698480" cy="3291840"/>
-          </a:xfrm>
-          <a:prstGeom prst="rect">
-            <a:avLst/>
-          </a:prstGeom>
-          <a:noFill/>
-        </p:spPr>
-        <p:txBody>
-          <a:bodyPr wrap="square">
-            <a:spAutoFit/>
-          </a:bodyPr>
-          <a:lstStyle/>
-          <a:p>
-            <a:pPr>
-              <a:defRPr sz="2000"/>
-            </a:pPr>
-            <a:r>
-              <a:t>Add the verified chart or evidence table for this slide. Separate observed facts from proposed actions.</a:t>
-            </a:r>
-          </a:p>
-        </p:txBody>
-      </p:sp>
-      <p:sp>
-        <p:nvSpPr>
-          <p:cNvPr id="4" name="TextBox 3"/>
-          <p:cNvSpPr txBox="1"/>
-          <p:nvPr/>
-        </p:nvSpPr>
-        <p:spPr>
-          <a:xfrm>
-            <a:off x="731520" y="6217920"/>
-            <a:ext cx="10698480" cy="320040"/>
-          </a:xfrm>
-          <a:prstGeom prst="rect">
-            <a:avLst/>
-          </a:prstGeom>
-          <a:noFill/>
-        </p:spPr>
-        <p:txBody>
-          <a:bodyPr wrap="none">
-            <a:spAutoFit/>
-          </a:bodyPr>
-          <a:lstStyle/>
-          <a:p>
-            <a:pPr>
-              <a:defRPr sz="1000"/>
-            </a:pPr>
-            <a:r>
-              <a:t>GenAI for Engineers v2.3 | Synthetic Northstar example | 2026-09-30 | All filters All | Slide7</a:t>
-            </a:r>
-          </a:p>
-        </p:txBody>
-      </p:sp>
-    </p:spTree>
-  </p:cSld>
-  <p:clrMapOvr>
-    <a:masterClrMapping/>
-  </p:clrMapOvr>
-</p:sld>
-</file>
-
-<file path=ppt/slides/slide8.xml><?xml version="1.0" encoding="utf-8"?>
-<p:sld xmlns:a="http://schemas.openxmlformats.org/drawingml/2006/main" xmlns:p="http://schemas.openxmlformats.org/presentationml/2006/main" xmlns:r="http://schemas.openxmlformats.org/officeDocument/2006/relationships">
-  <p:cSld>
-    <p:spTree>
-      <p:nvGrpSpPr>
-        <p:cNvPr id="1" name=""/>
-        <p:cNvGrpSpPr/>
-        <p:nvPr/>
-      </p:nvGrpSpPr>
-      <p:grpSpPr/>
-      <p:sp>
-        <p:nvSpPr>
-          <p:cNvPr id="2" name="TextBox 1"/>
-          <p:cNvSpPr txBox="1"/>
-          <p:nvPr/>
-        </p:nvSpPr>
-        <p:spPr>
-          <a:xfrm>
-            <a:off x="640080" y="457200"/>
-            <a:ext cx="10972800" cy="914400"/>
-          </a:xfrm>
-          <a:prstGeom prst="rect">
-            <a:avLst/>
-          </a:prstGeom>
-          <a:noFill/>
-        </p:spPr>
-        <p:txBody>
-          <a:bodyPr wrap="none">
-            <a:spAutoFit/>
-          </a:bodyPr>
-          <a:lstStyle/>
-          <a:p>
-            <a:pPr>
-              <a:defRPr sz="3000" b="1">
-                <a:solidFill>
-                  <a:srgbClr val="0B3060"/>
-                </a:solidFill>
-              </a:defRPr>
-            </a:pPr>
-            <a:r>
-              <a:t>Decision requested: review the recovery proposal</a:t>
-            </a:r>
-          </a:p>
-        </p:txBody>
-      </p:sp>
-      <p:sp>
-        <p:nvSpPr>
-          <p:cNvPr id="3" name="TextBox 2"/>
-          <p:cNvSpPr txBox="1"/>
-          <p:nvPr/>
-        </p:nvSpPr>
-        <p:spPr>
-          <a:xfrm>
-            <a:off x="731520" y="1508760"/>
-            <a:ext cx="10698480" cy="3291840"/>
-          </a:xfrm>
-          <a:prstGeom prst="rect">
-            <a:avLst/>
-          </a:prstGeom>
-          <a:noFill/>
-        </p:spPr>
-        <p:txBody>
-          <a:bodyPr wrap="square">
-            <a:spAutoFit/>
-          </a:bodyPr>
-          <a:lstStyle/>
-          <a:p>
-            <a:pPr>
-              <a:defRPr sz="2000"/>
-            </a:pPr>
-            <a:r>
-              <a:t>Add the verified chart or evidence table for this slide. Separate observed facts from proposed actions.</a:t>
-            </a:r>
-          </a:p>
-        </p:txBody>
-      </p:sp>
-      <p:sp>
-        <p:nvSpPr>
-          <p:cNvPr id="4" name="TextBox 3"/>
-          <p:cNvSpPr txBox="1"/>
-          <p:nvPr/>
-        </p:nvSpPr>
-        <p:spPr>
-          <a:xfrm>
-            <a:off x="731520" y="6217920"/>
-            <a:ext cx="10698480" cy="320040"/>
-          </a:xfrm>
-          <a:prstGeom prst="rect">
-            <a:avLst/>
-          </a:prstGeom>
-          <a:noFill/>
-        </p:spPr>
-        <p:txBody>
-          <a:bodyPr wrap="none">
-            <a:spAutoFit/>
-          </a:bodyPr>
-          <a:lstStyle/>
-          <a:p>
-            <a:pPr>
-              <a:defRPr sz="1000"/>
-            </a:pPr>
-            <a:r>
-              <a:t>GenAI for Engineers v2.3 | Synthetic Northstar example | 2026-09-30 | All filters All | Slide8</a:t>
+              <a:t>GenAI for Engineers v2.4 | Synthetic Northstar example | 2026-09-30 | All filters All | Slide4</a:t>
             </a:r>
           </a:p>
         </p:txBody>

</xml_diff>